<commit_message>
Student edition of the course site (built from course master 1efb59f, leak check PASS)
Phase II Learn pages (Weeks 8-14) with faded step 5, the load-error fix,
workload hours with any overrun stated, student wording without approval
status notes, and the layout pass (horizontal labels, text that fits at
laptop widths). Decks rebuilt; 0 speaker-note words in the student decks.

Co-Authored-By: Claude Opus 5.5 <noreply@anthropic.com>
</commit_message>
<xml_diff>
--- a/site/lectures/week02-session2.pptx
+++ b/site/lectures/week02-session2.pptx
@@ -11002,8 +11002,8 @@
         </p:blipFill>
         <p:spPr>
           <a:xfrm>
-            <a:off x="548640" y="1389149"/>
-            <a:ext cx="6379289" cy="4193240"/>
+            <a:off x="548640" y="1344114"/>
+            <a:ext cx="6379289" cy="4283309"/>
           </a:xfrm>
           <a:prstGeom prst="rect">
             <a:avLst/>

</xml_diff>